<commit_message>
Added glm and the GLFW.lib files
</commit_message>
<xml_diff>
--- a/Lectures/Day_01/INFO3111S26_W01_Course_Intro (long and boring PPT).pptx
+++ b/Lectures/Day_01/INFO3111S26_W01_Course_Intro (long and boring PPT).pptx
@@ -234,6 +234,37 @@
   </inkml:definitions>
   <inkml:trace contextRef="#ctx0" brushRef="#br0">23164 10914 0,'-66'-40'0,"0"27"0,-53-27 0,26 27 15,-13 13-15,-92-13 16,-27-13-16,-26-14 16,13 40-16,0 13 15,-27-13-15,67 27 16,-54-27 0,80 26-16,-13 0 15,39 1-15,1-14 16,66-13-16,-27 27 15,13-1-15,1 1 16,52 12-16,-13-26 16,26 67-16,1-54 15,13 1-15,13 26 16,0 0-16,-13-40 16,13 40-16,0 0 15,0-14-15,0-12 16,0 39-16,0 0 15,0 27-15,26 26 16,0 39-16,27 1 16,0-40-16,0 66 15,27-65 1,-28 38-16,28 1 16,-1-40-16,-13-40 15,1-12-15,12 12 16,-26-26-16,26 0 15,-26-27-15,26 1 16,14 26-16,0-40 16,26 0-16,0 27 15,13-14-15,0 1 16,-13-27-16,-52 0 16,12 0-16,-53 0 15,27 0-15,-39 0 16,-1 0-16,13 0 15,1 13 1,12-13-16,-25 0 16,39 0-16,-1 0 15,-12 0-15,53 13 16,-1 14-16,1-27 16,-27 13-1,27-13-15,-27 0 16,0 0-16,-13-13 15,0-1-15,26 1 16,-26-13-16,0 26 16,13-40-16,27 14 15,66-14-15,-67 27 16,67-1-16,-53 1 16,13-40-16,0 14 15,-40 25-15,1-52 16,-27 40-16,-27-1 15,0-26-15,14-13 16,-40 13-16,0-13 16,27 27-16,-14 12 15,-13-13-15,13 1 16,14-1-16,-1-13 16,-13 27-16,14-14 15,-1 0 1,1-26-16,-14 26 15,0-26-15,14 13 16,-27-39-16,26 39 16,-13 26-16,0-12 15,1 39-15,-14-40 16,0 27-16,0-27 16,0 0-16,-14-13 15,1 1-15,-26 25 16,-1-39-16,-26 13 15,0-13-15,13 26 16,0 14-16,0-1 16,-27 14-16,41 0 15,-27-14-15,-40 1 16,26-1-16,-12 1 16,39 0-16,0 12 15,13 28-15,14-28 16,26 1-1</inkml:trace>
   <inkml:trace contextRef="#ctx0" brushRef="#br0" timeOffset="1385.83">18891 9737 0,'-13'-27'0,"26"54"0,-79-80 15,-13 26-15,-40-12 16,0 12-16,-67-105 15,14 92-15,-79 0 16,26 1 0,27 39-16,-40-13 15,39-27-15,1 40 16,-1 0-16,41 0 16,12 0-16,14 0 15,39 0-15,14 13 16,66 0-16,-40 14 15,26 26-15,-13-14 16,14 14-16,0 13 16,-1 1-16,1 12 15,12 27-15,14 26 16,-13 14-16,13 26 16,0-27-16,13 1 15,27-14-15,26 13 16,0-12-16,27 12 15,13-26-15,39 27 16,1-14-16,-1-39 16,41 13-1,-28-14-15,1-39 16,26 13-16,-39 14 16,-14-54-16,14 53 15,-41-65-15,15-1 16,25-13-16,-26-13 15,27-27-15,26-13 16,-27-79-16,1 26 16,-80-53-16,26 14 15,-25 12-15,25-12 16,-39 52-16,13 14 16,-39 0-16,-14 39 15,13-26-15,-26 0 16,14 13-16,-14-14 15,0 28-15,0-27 16,-14 26 0,-12-13-16,13 13 15,-1 14-15,14-1 16,-13 14 0,13 0-1,0 0 1,0-14-1,0 1-15,0-1 16,-13 1 0,0 13-16,13-1 15,0 1-15</inkml:trace>
+</inkml:ink>
+</file>
+
+<file path=ppt/ink/ink2.xml><?xml version="1.0" encoding="utf-8"?>
+<inkml:ink xmlns:inkml="http://www.w3.org/2003/InkML">
+  <inkml:definitions>
+    <inkml:context xml:id="ctx0">
+      <inkml:inkSource xml:id="inkSrc0">
+        <inkml:traceFormat>
+          <inkml:channel name="X" type="integer" max="1920" units="cm"/>
+          <inkml:channel name="Y" type="integer" max="1080" units="cm"/>
+          <inkml:channel name="T" type="integer" max="2.14748E9" units="dev"/>
+        </inkml:traceFormat>
+        <inkml:channelProperties>
+          <inkml:channelProperty channel="X" name="resolution" value="55.81395" units="1/cm"/>
+          <inkml:channelProperty channel="Y" name="resolution" value="55.6701" units="1/cm"/>
+          <inkml:channelProperty channel="T" name="resolution" value="1" units="1/dev"/>
+        </inkml:channelProperties>
+      </inkml:inkSource>
+      <inkml:timestamp xml:id="ts0" timeString="2026-05-06T18:37:40.689"/>
+    </inkml:context>
+    <inkml:brush xml:id="br0">
+      <inkml:brushProperty name="width" value="0.05292" units="cm"/>
+      <inkml:brushProperty name="height" value="0.05292" units="cm"/>
+      <inkml:brushProperty name="color" value="#FF0000"/>
+    </inkml:brush>
+  </inkml:definitions>
+  <inkml:trace contextRef="#ctx0" brushRef="#br0">2553 9803 0,'93'0'109,"132"0"-93,119 0 0,-27 0-1,-13 0 1,-132 79-1,80-119 17,-80 40-17,-80-26-15,14 26 16,13 0 0,-66 0-16,27 0 15,-14 0 1,66 0 15,-13-26 0,27 26-15,52 0 15,80 0 16,-80 0-31,-105 0-1</inkml:trace>
+  <inkml:trace contextRef="#ctx0" brushRef="#br0" timeOffset="6562.33">16192 9856 0,'14'0'47,"144"0"-32,557 0 17,-239 0-17,291 0 17,-171 0-17,-305 0-15,555 0 31,200 26 1,-583-26-17,-67 0 1,226 27 15,-423-27-15,26 0 15,-120 0-15,-12 0-1,-14 0 1,-52 0-16,65 0 31,-65 0-15,-1 0 62</inkml:trace>
+  <inkml:trace contextRef="#ctx0" brushRef="#br0" timeOffset="17407.3">15981 8731 0,'79'0'94,"53"0"-78,411 0-1,-279 0 1,636 0 0,-622 0-1,635 0 1,-622 0-1,582-26 1,-569-1 0,556 27-1,331 0 17,-715-26-17,-225 26 1,-79 0-1,344 0 1,-291 0 0,-146 0-16,93 0 31,-132 0-15,145 13-1,-66-13 1,-92 0-1,39-13 1,-66 53 93,53 184-77,-53-131-32,0 211 31,0-158-15,0-14-1,0-39 1,26-40-1,1 66 1,-27-13 0,0-14-1,0-12 1,26-28 0,-26-38 62,-92-14-63,-133 0 1,-146 0 0,-92 0-1,-119 0 1,13 0-1,133 0 1,-411 0 15,477 0-15,-384 0 15,410 0-15,-27 0-1,80 0 1,133 26 0,-81-26-1,-12 0 1,-27 27 0,27-27-1,13-14 1,13 28-1,53-14 1,92 0-16,1 26 16,-212-39 15,119 13-15,-251-27 15,198 27-16,-53 0 17,238 0-17,14-26 32,-27 26-31,27 0 15,-27-27 32,39-12-48,-12-133 1,-53 13 15,52 40-15,27 66-16,0 27 15,13-67 1,-13 40-16,0-92 31,0 65-15,0 54-1,0-67 1,0 40 0,-13-39 15,13 65-15,0 1-1,0-1 16,0-26-15,0 27-16,0-14 31,13 14-15,40 26 125,40-80-126,13 54 1,-80 26-1,40 0 1,14-27 0,-27 27-1,13 0 1,-40 0-16,1 0 31,26 40 344,-53 13-344</inkml:trace>
+  <inkml:trace contextRef="#ctx0" brushRef="#br0" timeOffset="25860.12">15174 7408 0,'40'0'16,"237"-13"15,266 13-16,-67-26 17,-397 26-17</inkml:trace>
 </inkml:ink>
 </file>
 
@@ -12266,6 +12297,57 @@
           </a:p>
         </p:txBody>
       </p:sp>
+      <mc:AlternateContent xmlns:mc="http://schemas.openxmlformats.org/markup-compatibility/2006">
+        <mc:Choice xmlns:p14="http://schemas.microsoft.com/office/powerpoint/2010/main" Requires="p14">
+          <p:contentPart p14:bwMode="auto" r:id="rId2">
+            <p14:nvContentPartPr>
+              <p14:cNvPr id="2" name="Ink 1">
+                <a:extLst>
+                  <a:ext uri="{FF2B5EF4-FFF2-40B4-BE49-F238E27FC236}">
+                    <a16:creationId xmlns:a16="http://schemas.microsoft.com/office/drawing/2014/main" id="{4B528990-3104-D975-C5DF-D35CEC5C6476}"/>
+                  </a:ext>
+                </a:extLst>
+              </p14:cNvPr>
+              <p14:cNvContentPartPr/>
+              <p14:nvPr/>
+            </p14:nvContentPartPr>
+            <p14:xfrm>
+              <a:off x="919080" y="2652840"/>
+              <a:ext cx="8106120" cy="1047960"/>
+            </p14:xfrm>
+          </p:contentPart>
+        </mc:Choice>
+        <mc:Fallback>
+          <p:pic>
+            <p:nvPicPr>
+              <p:cNvPr id="2" name="Ink 1">
+                <a:extLst>
+                  <a:ext uri="{FF2B5EF4-FFF2-40B4-BE49-F238E27FC236}">
+                    <a16:creationId xmlns:a16="http://schemas.microsoft.com/office/drawing/2014/main" id="{4B528990-3104-D975-C5DF-D35CEC5C6476}"/>
+                  </a:ext>
+                </a:extLst>
+              </p:cNvPr>
+              <p:cNvPicPr/>
+              <p:nvPr/>
+            </p:nvPicPr>
+            <p:blipFill>
+              <a:blip r:embed="rId3"/>
+              <a:stretch>
+                <a:fillRect/>
+              </a:stretch>
+            </p:blipFill>
+            <p:spPr>
+              <a:xfrm>
+                <a:off x="909720" y="2643480"/>
+                <a:ext cx="8124840" cy="1066680"/>
+              </a:xfrm>
+              <a:prstGeom prst="rect">
+                <a:avLst/>
+              </a:prstGeom>
+            </p:spPr>
+          </p:pic>
+        </mc:Fallback>
+      </mc:AlternateContent>
     </p:spTree>
   </p:cSld>
   <p:clrMapOvr>

</xml_diff>